<commit_message>
pdf copies of intro slides
</commit_message>
<xml_diff>
--- a/docs/materials/welcome/files/osgs26-htc-intro.pptx
+++ b/docs/materials/welcome/files/osgs26-htc-intro.pptx
@@ -11972,12 +11972,20 @@
               </a:spcAft>
             </a:pPr>
             <a:r>
-              <a:rPr lang="en-US" dirty="0" err="1"/>
+              <a:rPr lang="en-US" dirty="0" err="1">
+                <a:hlinkClick r:id="rId3"/>
+              </a:rPr>
               <a:t>OSPool</a:t>
             </a:r>
             <a:r>
+              <a:rPr lang="en-US" dirty="0">
+                <a:hlinkClick r:id="rId3"/>
+              </a:rPr>
+              <a:t> Introduction </a:t>
+            </a:r>
+            <a:r>
               <a:rPr lang="en-US" dirty="0"/>
-              <a:t> Introduction (Tuesday)</a:t>
+              <a:t>(Tuesday)</a:t>
             </a:r>
           </a:p>
           <a:p>
@@ -11998,7 +12006,7 @@
             <a:pPr lvl="1"/>
             <a:r>
               <a:rPr lang="en-US" dirty="0">
-                <a:hlinkClick r:id="rId3"/>
+                <a:hlinkClick r:id="rId4"/>
               </a:rPr>
               <a:t>Main Page</a:t>
             </a:r>
@@ -12008,13 +12016,13 @@
             </a:r>
             <a:r>
               <a:rPr lang="en-US" dirty="0">
-                <a:hlinkClick r:id="rId4"/>
+                <a:hlinkClick r:id="rId5"/>
               </a:rPr>
               <a:t>Get Started on the </a:t>
             </a:r>
             <a:r>
               <a:rPr lang="en-US" dirty="0" err="1">
-                <a:hlinkClick r:id="rId4"/>
+                <a:hlinkClick r:id="rId5"/>
               </a:rPr>
               <a:t>OSPool</a:t>
             </a:r>
@@ -12031,7 +12039,7 @@
             </a:r>
             <a:r>
               <a:rPr lang="en-US" dirty="0">
-                <a:hlinkClick r:id="rId5"/>
+                <a:hlinkClick r:id="rId6"/>
               </a:rPr>
               <a:t>https://portal.osg-htc.org/</a:t>
             </a:r>
@@ -12272,12 +12280,20 @@
               </a:spcAft>
             </a:pPr>
             <a:r>
-              <a:rPr lang="en-US" dirty="0" err="1"/>
+              <a:rPr lang="en-US" dirty="0" err="1">
+                <a:hlinkClick r:id="rId3"/>
+              </a:rPr>
               <a:t>HTCondor</a:t>
             </a:r>
             <a:r>
+              <a:rPr lang="en-US" dirty="0">
+                <a:hlinkClick r:id="rId3"/>
+              </a:rPr>
+              <a:t> Introduction</a:t>
+            </a:r>
+            <a:r>
               <a:rPr lang="en-US" dirty="0"/>
-              <a:t> Introduction (Mon)</a:t>
+              <a:t> (Mon)</a:t>
             </a:r>
           </a:p>
           <a:p>
@@ -12290,8 +12306,14 @@
               </a:spcAft>
             </a:pPr>
             <a:r>
+              <a:rPr lang="en-US" dirty="0">
+                <a:hlinkClick r:id="rId4"/>
+              </a:rPr>
+              <a:t>Troubleshooting</a:t>
+            </a:r>
+            <a:r>
               <a:rPr lang="en-US" dirty="0"/>
-              <a:t>Troubleshooting (Thurs)</a:t>
+              <a:t> (Thurs)</a:t>
             </a:r>
           </a:p>
           <a:p>
@@ -12304,16 +12326,26 @@
               </a:spcAft>
             </a:pPr>
             <a:r>
+              <a:rPr lang="en-US" dirty="0">
+                <a:hlinkClick r:id="rId5"/>
+              </a:rPr>
+              <a:t>Workflows with </a:t>
+            </a:r>
+            <a:r>
+              <a:rPr lang="en-US" dirty="0" err="1">
+                <a:hlinkClick r:id="rId5"/>
+              </a:rPr>
+              <a:t>DAGMan</a:t>
+            </a:r>
+            <a:r>
+              <a:rPr lang="en-US" dirty="0">
+                <a:hlinkClick r:id="rId5"/>
+              </a:rPr>
+              <a:t> </a:t>
+            </a:r>
+            <a:r>
               <a:rPr lang="en-US" dirty="0"/>
-              <a:t>Workflows with </a:t>
-            </a:r>
-            <a:r>
-              <a:rPr lang="en-US" dirty="0" err="1"/>
-              <a:t>DAGMan</a:t>
-            </a:r>
-            <a:r>
-              <a:rPr lang="en-US" dirty="0"/>
-              <a:t> (Thurs)</a:t>
+              <a:t>(Thurs)</a:t>
             </a:r>
           </a:p>
           <a:p>
@@ -12341,7 +12373,7 @@
             </a:pPr>
             <a:r>
               <a:rPr lang="en-US" dirty="0">
-                <a:hlinkClick r:id="rId3"/>
+                <a:hlinkClick r:id="rId6"/>
               </a:rPr>
               <a:t>Main Page</a:t>
             </a:r>
@@ -12351,7 +12383,7 @@
             </a:r>
             <a:r>
               <a:rPr lang="en-US" dirty="0">
-                <a:hlinkClick r:id="rId4"/>
+                <a:hlinkClick r:id="rId7"/>
               </a:rPr>
               <a:t>Submit HTC Workloads</a:t>
             </a:r>
@@ -12371,7 +12403,7 @@
             </a:pPr>
             <a:r>
               <a:rPr lang="en-US" dirty="0">
-                <a:hlinkClick r:id="rId3"/>
+                <a:hlinkClick r:id="rId6"/>
               </a:rPr>
               <a:t>Main Page </a:t>
             </a:r>
@@ -12381,7 +12413,7 @@
             </a:r>
             <a:r>
               <a:rPr lang="en-US" dirty="0">
-                <a:hlinkClick r:id="rId4"/>
+                <a:hlinkClick r:id="rId7"/>
               </a:rPr>
               <a:t>Submit HTC Workloads</a:t>
             </a:r>
@@ -12590,8 +12622,14 @@
               </a:spcAft>
             </a:pPr>
             <a:r>
+              <a:rPr lang="en-US" dirty="0">
+                <a:hlinkClick r:id="rId3"/>
+              </a:rPr>
+              <a:t>Software</a:t>
+            </a:r>
+            <a:r>
               <a:rPr lang="en-US" dirty="0"/>
-              <a:t>Software (Tuesday)</a:t>
+              <a:t> (Tuesday)</a:t>
             </a:r>
           </a:p>
           <a:p>
@@ -12604,8 +12642,14 @@
               </a:spcAft>
             </a:pPr>
             <a:r>
+              <a:rPr lang="en-US" dirty="0">
+                <a:hlinkClick r:id="rId4"/>
+              </a:rPr>
+              <a:t>Data</a:t>
+            </a:r>
+            <a:r>
               <a:rPr lang="en-US" dirty="0"/>
-              <a:t>Data (Wednesday)</a:t>
+              <a:t> (Wednesday)</a:t>
             </a:r>
           </a:p>
           <a:p>
@@ -12633,7 +12677,7 @@
             </a:pPr>
             <a:r>
               <a:rPr lang="en-US" dirty="0">
-                <a:hlinkClick r:id="rId3"/>
+                <a:hlinkClick r:id="rId5"/>
               </a:rPr>
               <a:t>Main Page</a:t>
             </a:r>
@@ -12643,7 +12687,7 @@
             </a:r>
             <a:r>
               <a:rPr lang="en-US" dirty="0">
-                <a:hlinkClick r:id="rId4"/>
+                <a:hlinkClick r:id="rId6"/>
               </a:rPr>
               <a:t>Submit HTC Workloads</a:t>
             </a:r>
@@ -12663,7 +12707,7 @@
             </a:pPr>
             <a:r>
               <a:rPr lang="en-US" dirty="0">
-                <a:hlinkClick r:id="rId3"/>
+                <a:hlinkClick r:id="rId5"/>
               </a:rPr>
               <a:t>Main Page</a:t>
             </a:r>
@@ -12673,7 +12717,7 @@
             </a:r>
             <a:r>
               <a:rPr lang="en-US" dirty="0">
-                <a:hlinkClick r:id="rId4"/>
+                <a:hlinkClick r:id="rId6"/>
               </a:rPr>
               <a:t>Submit HTC Workloads</a:t>
             </a:r>
@@ -13788,23 +13832,7 @@
                 <a:ea typeface="Helvetica Neue Medium" panose="02000503000000020004" pitchFamily="2" charset="0"/>
                 <a:cs typeface="Helvetica Neue Medium" panose="02000503000000020004" pitchFamily="2" charset="0"/>
               </a:rPr>
-              <a:t>Don’t use any LLMs / </a:t>
-            </a:r>
-            <a:r>
-              <a:rPr lang="en-US" dirty="0">
-                <a:latin typeface="Helvetica Neue Medium" panose="02000503000000020004" pitchFamily="2" charset="0"/>
-                <a:ea typeface="Helvetica Neue Medium" panose="02000503000000020004" pitchFamily="2" charset="0"/>
-                <a:cs typeface="Helvetica Neue Medium" panose="02000503000000020004" pitchFamily="2" charset="0"/>
-              </a:rPr>
-              <a:t>AI agents </a:t>
-            </a:r>
-            <a:r>
-              <a:rPr lang="en-US" dirty="0">
-                <a:latin typeface="Helvetica Neue Medium" panose="02000503000000020004" pitchFamily="2" charset="0"/>
-                <a:ea typeface="Helvetica Neue Medium" panose="02000503000000020004" pitchFamily="2" charset="0"/>
-                <a:cs typeface="Helvetica Neue Medium" panose="02000503000000020004" pitchFamily="2" charset="0"/>
-              </a:rPr>
-              <a:t>for at least the first 2 days of the School. </a:t>
+              <a:t>Don’t use any LLMs / AI agents for at least the first 2 days of the School. </a:t>
             </a:r>
           </a:p>
           <a:p>

</xml_diff>